<commit_message>
Complete step-by-step visual guides for Lab 01
</commit_message>
<xml_diff>
--- a/slides/LAB01_Pengantar_Cloud_Hands_On_Final.pptx
+++ b/slides/LAB01_Pengantar_Cloud_Hands_On_Final.pptx
@@ -44,6 +44,8 @@
     <p:sldId id="289" r:id="rId35"/>
     <p:sldId id="290" r:id="rId36"/>
     <p:sldId id="291" r:id="rId37"/>
+    <p:sldId id="292" r:id="rId43"/>
+    <p:sldId id="293" r:id="rId44"/>
   </p:sldIdLst>
   <p:sldSz cx="12192000" cy="6858000"/>
   <p:notesSz cx="6858000" cy="12192000"/>
@@ -35806,6 +35808,1318 @@
         <p14:creationId xmlns:p14="http://schemas.microsoft.com/office/powerpoint/2010/main" val="1765685840"/>
       </p:ext>
     </p:extLst>
+  </p:cSld>
+  <p:clrMapOvr>
+    <a:masterClrMapping/>
+  </p:clrMapOvr>
+</p:sld>
+</file>
+
+<file path=ppt/slides/slide37.xml><?xml version="1.0" encoding="utf-8"?>
+<p:sld xmlns:a="http://schemas.openxmlformats.org/drawingml/2006/main" xmlns:p="http://schemas.openxmlformats.org/presentationml/2006/main" xmlns:r="http://schemas.openxmlformats.org/officeDocument/2006/relationships">
+  <p:cSld>
+    <p:spTree>
+      <p:nvGrpSpPr>
+        <p:cNvPr id="1" name=""/>
+        <p:cNvGrpSpPr/>
+        <p:nvPr/>
+      </p:nvGrpSpPr>
+      <p:grpSpPr/>
+      <p:sp>
+        <p:nvSpPr>
+          <p:cNvPr id="2" name="Text 0"/>
+          <p:cNvSpPr/>
+          <p:nvPr/>
+        </p:nvSpPr>
+        <p:spPr>
+          <a:xfrm>
+            <a:off x="457200" y="6492240"/>
+            <a:ext cx="7315200" cy="274320"/>
+          </a:xfrm>
+          <a:prstGeom prst="rect">
+            <a:avLst/>
+          </a:prstGeom>
+          <a:noFill/>
+          <a:ln/>
+        </p:spPr>
+        <p:txBody>
+          <a:bodyPr wrap="square" lIns="0" tIns="0" rIns="0" bIns="0" rtlCol="0" anchor="ctr"/>
+          <a:lstStyle/>
+          <a:p>
+            <a:pPr marL="0" indent="0" algn="l">
+              <a:buNone/>
+            </a:pPr>
+            <a:r>
+              <a:rPr lang="en-US" sz="900" dirty="0">
+                <a:solidFill>
+                  <a:srgbClr val="64748B"/>
+                </a:solidFill>
+                <a:latin typeface="Calibri" pitchFamily="34" charset="0"/>
+                <a:ea typeface="Calibri" pitchFamily="34" charset="-122"/>
+                <a:cs typeface="Calibri" pitchFamily="34" charset="-120"/>
+              </a:rPr>
+              <a:t>BINUS UNIVERSITY  |  Cloud Services  |  Praktikum 1</a:t>
+            </a:r>
+            <a:endParaRPr lang="en-US" sz="900" dirty="0"/>
+          </a:p>
+        </p:txBody>
+      </p:sp>
+      <p:sp>
+        <p:nvSpPr>
+          <p:cNvPr id="3" name="Text 1"/>
+          <p:cNvSpPr/>
+          <p:nvPr/>
+        </p:nvSpPr>
+        <p:spPr>
+          <a:xfrm>
+            <a:off x="11247120" y="6492240"/>
+            <a:ext cx="457200" cy="274320"/>
+          </a:xfrm>
+          <a:prstGeom prst="rect">
+            <a:avLst/>
+          </a:prstGeom>
+          <a:noFill/>
+          <a:ln/>
+        </p:spPr>
+        <p:txBody>
+          <a:bodyPr wrap="square" lIns="0" tIns="0" rIns="0" bIns="0" rtlCol="0" anchor="ctr"/>
+          <a:lstStyle/>
+          <a:p>
+            <a:pPr marL="0" indent="0" algn="r">
+              <a:buNone/>
+            </a:pPr>
+            <a:r>
+              <a:rPr lang="en-US" sz="900" b="1">
+                <a:solidFill>
+                  <a:srgbClr val="64748B"/>
+                </a:solidFill>
+                <a:latin typeface="Calibri" pitchFamily="34" charset="0"/>
+                <a:ea typeface="Calibri" pitchFamily="34" charset="-122"/>
+                <a:cs typeface="Calibri" pitchFamily="34" charset="-120"/>
+              </a:rPr>
+              <a:t>37</a:t>
+            </a:r>
+            <a:endParaRPr lang="en-US" sz="900" dirty="0"/>
+          </a:p>
+        </p:txBody>
+      </p:sp>
+      <p:sp>
+        <p:nvSpPr>
+          <p:cNvPr id="4" name="Shape 2"/>
+          <p:cNvSpPr/>
+          <p:nvPr/>
+        </p:nvSpPr>
+        <p:spPr>
+          <a:xfrm>
+            <a:off x="457200" y="6446520"/>
+            <a:ext cx="228600" cy="36576"/>
+          </a:xfrm>
+          <a:prstGeom prst="rect">
+            <a:avLst/>
+          </a:prstGeom>
+          <a:solidFill>
+            <a:srgbClr val="F37021"/>
+          </a:solidFill>
+          <a:ln w="12700">
+            <a:solidFill>
+              <a:srgbClr val="F37021"/>
+            </a:solidFill>
+            <a:prstDash val="solid"/>
+          </a:ln>
+        </p:spPr>
+      </p:sp>
+      <p:pic>
+        <p:nvPicPr>
+          <p:cNvPr id="5" name="Picture 4" descr="image.png"/>
+          <p:cNvPicPr>
+            <a:picLocks noChangeAspect="1"/>
+          </p:cNvPicPr>
+          <p:nvPr/>
+        </p:nvPicPr>
+        <p:blipFill>
+          <a:blip r:embed="rId2"/>
+          <a:stretch>
+            <a:fillRect/>
+          </a:stretch>
+        </p:blipFill>
+        <p:spPr>
+          <a:xfrm>
+            <a:off x="274320" y="164592"/>
+            <a:ext cx="914400" cy="603504"/>
+          </a:xfrm>
+          <a:prstGeom prst="rect">
+            <a:avLst/>
+          </a:prstGeom>
+        </p:spPr>
+      </p:pic>
+      <p:pic>
+        <p:nvPicPr>
+          <p:cNvPr id="6" name="Picture 5" descr="image.png"/>
+          <p:cNvPicPr>
+            <a:picLocks noChangeAspect="1"/>
+          </p:cNvPicPr>
+          <p:nvPr/>
+        </p:nvPicPr>
+        <p:blipFill>
+          <a:blip r:embed="rId3"/>
+          <a:stretch>
+            <a:fillRect/>
+          </a:stretch>
+        </p:blipFill>
+        <p:spPr>
+          <a:xfrm>
+            <a:off x="10881360" y="182880"/>
+            <a:ext cx="1005840" cy="512064"/>
+          </a:xfrm>
+          <a:prstGeom prst="rect">
+            <a:avLst/>
+          </a:prstGeom>
+        </p:spPr>
+      </p:pic>
+      <p:sp>
+        <p:nvSpPr>
+          <p:cNvPr id="7" name="Shape 3"/>
+          <p:cNvSpPr/>
+          <p:nvPr/>
+        </p:nvSpPr>
+        <p:spPr>
+          <a:xfrm>
+            <a:off x="457200" y="868680"/>
+            <a:ext cx="11247120" cy="0"/>
+          </a:xfrm>
+          <a:prstGeom prst="line">
+            <a:avLst/>
+          </a:prstGeom>
+          <a:noFill/>
+          <a:ln w="12700">
+            <a:solidFill>
+              <a:srgbClr val="E2E8F0"/>
+            </a:solidFill>
+            <a:prstDash val="solid"/>
+          </a:ln>
+        </p:spPr>
+      </p:sp>
+      <p:sp>
+        <p:nvSpPr>
+          <p:cNvPr id="8" name="Text 4"/>
+          <p:cNvSpPr/>
+          <p:nvPr/>
+        </p:nvSpPr>
+        <p:spPr>
+          <a:xfrm>
+            <a:off x="2011680" y="182880"/>
+            <a:ext cx="8138160" cy="502920"/>
+          </a:xfrm>
+          <a:prstGeom prst="rect">
+            <a:avLst/>
+          </a:prstGeom>
+          <a:noFill/>
+          <a:ln/>
+        </p:spPr>
+        <p:txBody>
+          <a:bodyPr wrap="square" lIns="0" tIns="0" rIns="0" bIns="0" rtlCol="0" anchor="ctr"/>
+          <a:lstStyle/>
+          <a:p>
+            <a:pPr marL="0" indent="0" algn="ctr">
+              <a:buNone/>
+            </a:pPr>
+            <a:r>
+              <a:rPr lang="nl-NL" sz="2200" b="1">
+                <a:solidFill>
+                  <a:srgbClr val="1976D2"/>
+                </a:solidFill>
+                <a:latin typeface="Calibri" pitchFamily="34" charset="0"/>
+                <a:ea typeface="Calibri" pitchFamily="34" charset="-122"/>
+                <a:cs typeface="Calibri" pitchFamily="34" charset="-120"/>
+              </a:rPr>
+              <a:t>Bukti langkah 1 | student.json dan tes</a:t>
+            </a:r>
+            <a:endParaRPr lang="en-US" sz="2200" dirty="0"/>
+          </a:p>
+        </p:txBody>
+      </p:sp>
+      <p:sp>
+        <p:nvSpPr>
+          <p:cNvPr id="9" name="Text 5"/>
+          <p:cNvSpPr/>
+          <p:nvPr/>
+        </p:nvSpPr>
+        <p:spPr>
+          <a:xfrm>
+            <a:off x="457200" y="960120"/>
+            <a:ext cx="11247120" cy="320040"/>
+          </a:xfrm>
+          <a:prstGeom prst="rect">
+            <a:avLst/>
+          </a:prstGeom>
+          <a:noFill/>
+          <a:ln/>
+        </p:spPr>
+        <p:txBody>
+          <a:bodyPr wrap="square" lIns="0" tIns="0" rIns="0" bIns="0" rtlCol="0" anchor="ctr"/>
+          <a:lstStyle/>
+          <a:p>
+            <a:pPr marL="0" indent="0" algn="ctr">
+              <a:buNone/>
+            </a:pPr>
+            <a:r>
+              <a:rPr lang="en-US" sz="1200" i="1">
+                <a:solidFill>
+                  <a:srgbClr val="64748B"/>
+                </a:solidFill>
+                <a:latin typeface="Calibri" pitchFamily="34" charset="0"/>
+                <a:ea typeface="Calibri" pitchFamily="34" charset="-122"/>
+                <a:cs typeface="Calibri" pitchFamily="34" charset="-120"/>
+              </a:rPr>
+              <a:t>Get-Content student.json; npm test  |  render output aktual</a:t>
+            </a:r>
+            <a:endParaRPr lang="en-US" sz="1200" dirty="0"/>
+          </a:p>
+        </p:txBody>
+      </p:sp>
+      <p:sp>
+        <p:nvSpPr>
+          <p:cNvPr id="27" name="Rectangle 26">
+            <a:extLst>
+              <a:ext uri="{FF2B5EF4-FFF2-40B4-BE49-F238E27FC236}">
+                <a16:creationId xmlns:a16="http://schemas.microsoft.com/office/drawing/2014/main" id="{CA2C3FC3-2268-3632-60A5-8F36FCCD90BB}"/>
+              </a:ext>
+            </a:extLst>
+          </p:cNvPr>
+          <p:cNvSpPr/>
+          <p:nvPr/>
+        </p:nvSpPr>
+        <p:spPr>
+          <a:xfrm>
+            <a:off x="457200" y="1409700"/>
+            <a:ext cx="11252200" cy="3886200"/>
+          </a:xfrm>
+          <a:prstGeom prst="rect">
+            <a:avLst/>
+          </a:prstGeom>
+          <a:solidFill>
+            <a:srgbClr val="F6F8FC"/>
+          </a:solidFill>
+          <a:ln>
+            <a:solidFill>
+              <a:srgbClr val="D3DEEE"/>
+            </a:solidFill>
+          </a:ln>
+        </p:spPr>
+        <p:style>
+          <a:lnRef idx="2">
+            <a:schemeClr val="accent1">
+              <a:shade val="15000"/>
+            </a:schemeClr>
+          </a:lnRef>
+          <a:fillRef idx="1">
+            <a:schemeClr val="accent1"/>
+          </a:fillRef>
+          <a:effectRef idx="0">
+            <a:schemeClr val="accent1"/>
+          </a:effectRef>
+          <a:fontRef idx="minor">
+            <a:schemeClr val="lt1"/>
+          </a:fontRef>
+        </p:style>
+        <p:txBody>
+          <a:bodyPr rtlCol="0" anchor="ctr"/>
+          <a:lstStyle/>
+          <a:p>
+            <a:pPr algn="ctr"/>
+            <a:endParaRPr lang="en-US"/>
+          </a:p>
+        </p:txBody>
+      </p:sp>
+      <p:sp>
+        <p:nvSpPr>
+          <p:cNvPr id="30" name="Rectangle 29">
+            <a:extLst>
+              <a:ext uri="{FF2B5EF4-FFF2-40B4-BE49-F238E27FC236}">
+                <a16:creationId xmlns:a16="http://schemas.microsoft.com/office/drawing/2014/main" id="{784C38AF-D50D-3EDB-2A20-35E588144107}"/>
+              </a:ext>
+            </a:extLst>
+          </p:cNvPr>
+          <p:cNvSpPr/>
+          <p:nvPr/>
+        </p:nvSpPr>
+        <p:spPr>
+          <a:xfrm>
+            <a:off x="457200" y="5397500"/>
+            <a:ext cx="11252200" cy="787400"/>
+          </a:xfrm>
+          <a:prstGeom prst="rect">
+            <a:avLst/>
+          </a:prstGeom>
+          <a:solidFill>
+            <a:srgbClr val="002777"/>
+          </a:solidFill>
+          <a:ln w="12700" cap="flat" cmpd="sng" algn="ctr">
+            <a:noFill/>
+            <a:prstDash val="solid"/>
+            <a:miter lim="800000"/>
+          </a:ln>
+          <a:effectLst/>
+          <a:extLst>
+            <a:ext uri="{91240B29-F687-4F45-9708-019B960494DF}">
+              <a14:hiddenLine xmlns:a14="http://schemas.microsoft.com/office/drawing/2010/main" w="12700" cap="flat" cmpd="sng" algn="ctr">
+                <a:solidFill>
+                  <a:schemeClr val="accent1">
+                    <a:shade val="15000"/>
+                  </a:schemeClr>
+                </a:solidFill>
+                <a:prstDash val="solid"/>
+                <a:miter lim="800000"/>
+              </a14:hiddenLine>
+            </a:ext>
+          </a:extLst>
+        </p:spPr>
+        <p:style>
+          <a:lnRef idx="2">
+            <a:schemeClr val="accent1">
+              <a:shade val="15000"/>
+            </a:schemeClr>
+          </a:lnRef>
+          <a:fillRef idx="1">
+            <a:schemeClr val="accent1"/>
+          </a:fillRef>
+          <a:effectRef idx="0">
+            <a:schemeClr val="accent1"/>
+          </a:effectRef>
+          <a:fontRef idx="minor">
+            <a:schemeClr val="lt1"/>
+          </a:fontRef>
+        </p:style>
+        <p:txBody>
+          <a:bodyPr rtlCol="0" anchor="ctr"/>
+          <a:lstStyle/>
+          <a:p>
+            <a:pPr algn="ctr"/>
+            <a:endParaRPr lang="en-US"/>
+          </a:p>
+        </p:txBody>
+      </p:sp>
+      <p:sp>
+        <p:nvSpPr>
+          <p:cNvPr id="31" name="TextBox 30">
+            <a:extLst>
+              <a:ext uri="{FF2B5EF4-FFF2-40B4-BE49-F238E27FC236}">
+                <a16:creationId xmlns:a16="http://schemas.microsoft.com/office/drawing/2014/main" id="{78179848-0254-FC95-B234-981E0248F004}"/>
+              </a:ext>
+            </a:extLst>
+          </p:cNvPr>
+          <p:cNvSpPr txBox="1"/>
+          <p:nvPr/>
+        </p:nvSpPr>
+        <p:spPr>
+          <a:xfrm>
+            <a:off x="635000" y="5499100"/>
+            <a:ext cx="3429000" cy="276999"/>
+          </a:xfrm>
+          <a:prstGeom prst="rect">
+            <a:avLst/>
+          </a:prstGeom>
+          <a:noFill/>
+        </p:spPr>
+        <p:txBody>
+          <a:bodyPr vert="horz" wrap="square" lIns="0" tIns="0" rIns="0" bIns="0" rtlCol="0">
+            <a:noAutofit/>
+          </a:bodyPr>
+          <a:lstStyle/>
+          <a:p>
+            <a:r>
+              <a:rPr lang="en-US" sz="1050" b="1">
+                <a:solidFill>
+                  <a:srgbClr val="F37021"/>
+                </a:solidFill>
+                <a:latin typeface="Arial" panose="020B0604020202020204" pitchFamily="34" charset="0"/>
+              </a:rPr>
+              <a:t>IDENTITAS</a:t>
+            </a:r>
+          </a:p>
+        </p:txBody>
+      </p:sp>
+      <p:sp>
+        <p:nvSpPr>
+          <p:cNvPr id="32" name="TextBox 31">
+            <a:extLst>
+              <a:ext uri="{FF2B5EF4-FFF2-40B4-BE49-F238E27FC236}">
+                <a16:creationId xmlns:a16="http://schemas.microsoft.com/office/drawing/2014/main" id="{9F041FD0-C768-9242-FF37-021E9D2B6BD9}"/>
+              </a:ext>
+            </a:extLst>
+          </p:cNvPr>
+          <p:cNvSpPr txBox="1"/>
+          <p:nvPr/>
+        </p:nvSpPr>
+        <p:spPr>
+          <a:xfrm>
+            <a:off x="635000" y="5727700"/>
+            <a:ext cx="3429000" cy="276999"/>
+          </a:xfrm>
+          <a:prstGeom prst="rect">
+            <a:avLst/>
+          </a:prstGeom>
+          <a:noFill/>
+        </p:spPr>
+        <p:txBody>
+          <a:bodyPr vert="horz" wrap="square" lIns="0" tIns="0" rIns="0" bIns="0" rtlCol="0">
+            <a:noAutofit/>
+          </a:bodyPr>
+          <a:lstStyle/>
+          <a:p>
+            <a:r>
+              <a:rPr lang="en-US" sz="1300">
+                <a:solidFill>
+                  <a:srgbClr val="FFFFFF"/>
+                </a:solidFill>
+                <a:latin typeface="Arial" panose="020B0604020202020204" pitchFamily="34" charset="0"/>
+              </a:rPr>
+              <a:t>Ganti tiga nilai contoh</a:t>
+            </a:r>
+          </a:p>
+        </p:txBody>
+      </p:sp>
+      <p:sp>
+        <p:nvSpPr>
+          <p:cNvPr id="33" name="TextBox 32">
+            <a:extLst>
+              <a:ext uri="{FF2B5EF4-FFF2-40B4-BE49-F238E27FC236}">
+                <a16:creationId xmlns:a16="http://schemas.microsoft.com/office/drawing/2014/main" id="{AF74B100-F150-BE1A-A13C-CBD2FCE7D19B}"/>
+              </a:ext>
+            </a:extLst>
+          </p:cNvPr>
+          <p:cNvSpPr txBox="1"/>
+          <p:nvPr/>
+        </p:nvSpPr>
+        <p:spPr>
+          <a:xfrm>
+            <a:off x="4318000" y="5499100"/>
+            <a:ext cx="3429000" cy="276999"/>
+          </a:xfrm>
+          <a:prstGeom prst="rect">
+            <a:avLst/>
+          </a:prstGeom>
+          <a:noFill/>
+        </p:spPr>
+        <p:txBody>
+          <a:bodyPr vert="horz" wrap="square" lIns="0" tIns="0" rIns="0" bIns="0" rtlCol="0">
+            <a:noAutofit/>
+          </a:bodyPr>
+          <a:lstStyle/>
+          <a:p>
+            <a:r>
+              <a:rPr lang="en-US" sz="1050" b="1">
+                <a:solidFill>
+                  <a:srgbClr val="F37021"/>
+                </a:solidFill>
+                <a:latin typeface="Arial" panose="020B0604020202020204" pitchFamily="34" charset="0"/>
+              </a:rPr>
+              <a:t>UJI KODE</a:t>
+            </a:r>
+          </a:p>
+        </p:txBody>
+      </p:sp>
+      <p:sp>
+        <p:nvSpPr>
+          <p:cNvPr id="34" name="TextBox 33">
+            <a:extLst>
+              <a:ext uri="{FF2B5EF4-FFF2-40B4-BE49-F238E27FC236}">
+                <a16:creationId xmlns:a16="http://schemas.microsoft.com/office/drawing/2014/main" id="{B864305D-94C1-CBA2-4912-2EC5B118054C}"/>
+              </a:ext>
+            </a:extLst>
+          </p:cNvPr>
+          <p:cNvSpPr txBox="1"/>
+          <p:nvPr/>
+        </p:nvSpPr>
+        <p:spPr>
+          <a:xfrm>
+            <a:off x="4318000" y="5727700"/>
+            <a:ext cx="3429000" cy="276999"/>
+          </a:xfrm>
+          <a:prstGeom prst="rect">
+            <a:avLst/>
+          </a:prstGeom>
+          <a:noFill/>
+        </p:spPr>
+        <p:txBody>
+          <a:bodyPr vert="horz" wrap="square" lIns="0" tIns="0" rIns="0" bIns="0" rtlCol="0">
+            <a:noAutofit/>
+          </a:bodyPr>
+          <a:lstStyle/>
+          <a:p>
+            <a:r>
+              <a:rPr lang="en-US" sz="1300">
+                <a:solidFill>
+                  <a:srgbClr val="FFFFFF"/>
+                </a:solidFill>
+                <a:latin typeface="Arial" panose="020B0604020202020204" pitchFamily="34" charset="0"/>
+              </a:rPr>
+              <a:t>18 lulus, 0 gagal</a:t>
+            </a:r>
+          </a:p>
+        </p:txBody>
+      </p:sp>
+      <p:sp>
+        <p:nvSpPr>
+          <p:cNvPr id="35" name="TextBox 34">
+            <a:extLst>
+              <a:ext uri="{FF2B5EF4-FFF2-40B4-BE49-F238E27FC236}">
+                <a16:creationId xmlns:a16="http://schemas.microsoft.com/office/drawing/2014/main" id="{7FEE0EF9-5060-12FC-A5E6-E5367599FF83}"/>
+              </a:ext>
+            </a:extLst>
+          </p:cNvPr>
+          <p:cNvSpPr txBox="1"/>
+          <p:nvPr/>
+        </p:nvSpPr>
+        <p:spPr>
+          <a:xfrm>
+            <a:off x="8001000" y="5499100"/>
+            <a:ext cx="3429000" cy="276999"/>
+          </a:xfrm>
+          <a:prstGeom prst="rect">
+            <a:avLst/>
+          </a:prstGeom>
+          <a:noFill/>
+        </p:spPr>
+        <p:txBody>
+          <a:bodyPr vert="horz" wrap="square" lIns="0" tIns="0" rIns="0" bIns="0" rtlCol="0">
+            <a:noAutofit/>
+          </a:bodyPr>
+          <a:lstStyle/>
+          <a:p>
+            <a:r>
+              <a:rPr lang="en-US" sz="1050" b="1">
+                <a:solidFill>
+                  <a:srgbClr val="F37021"/>
+                </a:solidFill>
+                <a:latin typeface="Arial" panose="020B0604020202020204" pitchFamily="34" charset="0"/>
+              </a:rPr>
+              <a:t>CATATAN</a:t>
+            </a:r>
+          </a:p>
+        </p:txBody>
+      </p:sp>
+      <p:sp>
+        <p:nvSpPr>
+          <p:cNvPr id="36" name="TextBox 35">
+            <a:extLst>
+              <a:ext uri="{FF2B5EF4-FFF2-40B4-BE49-F238E27FC236}">
+                <a16:creationId xmlns:a16="http://schemas.microsoft.com/office/drawing/2014/main" id="{B7FAF8FA-E512-3BA5-B85A-15159888CAEB}"/>
+              </a:ext>
+            </a:extLst>
+          </p:cNvPr>
+          <p:cNvSpPr txBox="1"/>
+          <p:nvPr/>
+        </p:nvSpPr>
+        <p:spPr>
+          <a:xfrm>
+            <a:off x="8001000" y="5727700"/>
+            <a:ext cx="3429000" cy="276999"/>
+          </a:xfrm>
+          <a:prstGeom prst="rect">
+            <a:avLst/>
+          </a:prstGeom>
+          <a:noFill/>
+        </p:spPr>
+        <p:txBody>
+          <a:bodyPr vert="horz" wrap="square" lIns="0" tIns="0" rIns="0" bIns="0" rtlCol="0">
+            <a:noAutofit/>
+          </a:bodyPr>
+          <a:lstStyle/>
+          <a:p>
+            <a:r>
+              <a:rPr lang="en-US" sz="1300">
+                <a:solidFill>
+                  <a:srgbClr val="FFFFFF"/>
+                </a:solidFill>
+                <a:latin typeface="Arial" panose="020B0604020202020204" pitchFamily="34" charset="0"/>
+              </a:rPr>
+              <a:t>Tes hijau belum cek identitas</a:t>
+            </a:r>
+          </a:p>
+        </p:txBody>
+      </p:sp>
+      <p:pic>
+        <p:nvPicPr>
+          <p:cNvPr id="37" name="Picture 36" descr="image.png"/>
+          <p:cNvPicPr>
+            <a:picLocks noChangeAspect="1"/>
+          </p:cNvPicPr>
+          <p:nvPr/>
+        </p:nvPicPr>
+        <p:blipFill>
+          <a:blip r:embed="rId4"/>
+          <a:stretch>
+            <a:fillRect/>
+          </a:stretch>
+        </p:blipFill>
+        <p:spPr>
+          <a:xfrm>
+            <a:off x="2238665" y="1490898"/>
+            <a:ext cx="7689270" cy="3723804"/>
+          </a:xfrm>
+          <a:prstGeom prst="rect">
+            <a:avLst/>
+          </a:prstGeom>
+        </p:spPr>
+      </p:pic>
+    </p:spTree>
+  </p:cSld>
+  <p:clrMapOvr>
+    <a:masterClrMapping/>
+  </p:clrMapOvr>
+</p:sld>
+</file>
+
+<file path=ppt/slides/slide38.xml><?xml version="1.0" encoding="utf-8"?>
+<p:sld xmlns:a="http://schemas.openxmlformats.org/drawingml/2006/main" xmlns:p="http://schemas.openxmlformats.org/presentationml/2006/main" xmlns:r="http://schemas.openxmlformats.org/officeDocument/2006/relationships">
+  <p:cSld>
+    <p:spTree>
+      <p:nvGrpSpPr>
+        <p:cNvPr id="1" name=""/>
+        <p:cNvGrpSpPr/>
+        <p:nvPr/>
+      </p:nvGrpSpPr>
+      <p:grpSpPr/>
+      <p:sp>
+        <p:nvSpPr>
+          <p:cNvPr id="2" name="Text 0"/>
+          <p:cNvSpPr/>
+          <p:nvPr/>
+        </p:nvSpPr>
+        <p:spPr>
+          <a:xfrm>
+            <a:off x="457200" y="6492240"/>
+            <a:ext cx="7315200" cy="274320"/>
+          </a:xfrm>
+          <a:prstGeom prst="rect">
+            <a:avLst/>
+          </a:prstGeom>
+          <a:noFill/>
+          <a:ln/>
+        </p:spPr>
+        <p:txBody>
+          <a:bodyPr wrap="square" lIns="0" tIns="0" rIns="0" bIns="0" rtlCol="0" anchor="ctr"/>
+          <a:lstStyle/>
+          <a:p>
+            <a:pPr marL="0" indent="0" algn="l">
+              <a:buNone/>
+            </a:pPr>
+            <a:r>
+              <a:rPr lang="en-US" sz="900" dirty="0">
+                <a:solidFill>
+                  <a:srgbClr val="64748B"/>
+                </a:solidFill>
+                <a:latin typeface="Calibri" pitchFamily="34" charset="0"/>
+                <a:ea typeface="Calibri" pitchFamily="34" charset="-122"/>
+                <a:cs typeface="Calibri" pitchFamily="34" charset="-120"/>
+              </a:rPr>
+              <a:t>BINUS UNIVERSITY  |  Cloud Services  |  Praktikum 1</a:t>
+            </a:r>
+            <a:endParaRPr lang="en-US" sz="900" dirty="0"/>
+          </a:p>
+        </p:txBody>
+      </p:sp>
+      <p:sp>
+        <p:nvSpPr>
+          <p:cNvPr id="3" name="Text 1"/>
+          <p:cNvSpPr/>
+          <p:nvPr/>
+        </p:nvSpPr>
+        <p:spPr>
+          <a:xfrm>
+            <a:off x="11247120" y="6492240"/>
+            <a:ext cx="457200" cy="274320"/>
+          </a:xfrm>
+          <a:prstGeom prst="rect">
+            <a:avLst/>
+          </a:prstGeom>
+          <a:noFill/>
+          <a:ln/>
+        </p:spPr>
+        <p:txBody>
+          <a:bodyPr wrap="square" lIns="0" tIns="0" rIns="0" bIns="0" rtlCol="0" anchor="ctr"/>
+          <a:lstStyle/>
+          <a:p>
+            <a:pPr marL="0" indent="0" algn="r">
+              <a:buNone/>
+            </a:pPr>
+            <a:r>
+              <a:rPr lang="en-US" sz="900" b="1">
+                <a:solidFill>
+                  <a:srgbClr val="64748B"/>
+                </a:solidFill>
+                <a:latin typeface="Calibri" pitchFamily="34" charset="0"/>
+                <a:ea typeface="Calibri" pitchFamily="34" charset="-122"/>
+                <a:cs typeface="Calibri" pitchFamily="34" charset="-120"/>
+              </a:rPr>
+              <a:t>38</a:t>
+            </a:r>
+            <a:endParaRPr lang="en-US" sz="900" dirty="0"/>
+          </a:p>
+        </p:txBody>
+      </p:sp>
+      <p:sp>
+        <p:nvSpPr>
+          <p:cNvPr id="4" name="Shape 2"/>
+          <p:cNvSpPr/>
+          <p:nvPr/>
+        </p:nvSpPr>
+        <p:spPr>
+          <a:xfrm>
+            <a:off x="457200" y="6446520"/>
+            <a:ext cx="228600" cy="36576"/>
+          </a:xfrm>
+          <a:prstGeom prst="rect">
+            <a:avLst/>
+          </a:prstGeom>
+          <a:solidFill>
+            <a:srgbClr val="F37021"/>
+          </a:solidFill>
+          <a:ln w="12700">
+            <a:solidFill>
+              <a:srgbClr val="F37021"/>
+            </a:solidFill>
+            <a:prstDash val="solid"/>
+          </a:ln>
+        </p:spPr>
+      </p:sp>
+      <p:pic>
+        <p:nvPicPr>
+          <p:cNvPr id="5" name="Picture 4" descr="image.png"/>
+          <p:cNvPicPr>
+            <a:picLocks noChangeAspect="1"/>
+          </p:cNvPicPr>
+          <p:nvPr/>
+        </p:nvPicPr>
+        <p:blipFill>
+          <a:blip r:embed="rId2"/>
+          <a:stretch>
+            <a:fillRect/>
+          </a:stretch>
+        </p:blipFill>
+        <p:spPr>
+          <a:xfrm>
+            <a:off x="274320" y="164592"/>
+            <a:ext cx="914400" cy="603504"/>
+          </a:xfrm>
+          <a:prstGeom prst="rect">
+            <a:avLst/>
+          </a:prstGeom>
+        </p:spPr>
+      </p:pic>
+      <p:pic>
+        <p:nvPicPr>
+          <p:cNvPr id="6" name="Picture 5" descr="image.png"/>
+          <p:cNvPicPr>
+            <a:picLocks noChangeAspect="1"/>
+          </p:cNvPicPr>
+          <p:nvPr/>
+        </p:nvPicPr>
+        <p:blipFill>
+          <a:blip r:embed="rId3"/>
+          <a:stretch>
+            <a:fillRect/>
+          </a:stretch>
+        </p:blipFill>
+        <p:spPr>
+          <a:xfrm>
+            <a:off x="10881360" y="182880"/>
+            <a:ext cx="1005840" cy="512064"/>
+          </a:xfrm>
+          <a:prstGeom prst="rect">
+            <a:avLst/>
+          </a:prstGeom>
+        </p:spPr>
+      </p:pic>
+      <p:sp>
+        <p:nvSpPr>
+          <p:cNvPr id="7" name="Shape 3"/>
+          <p:cNvSpPr/>
+          <p:nvPr/>
+        </p:nvSpPr>
+        <p:spPr>
+          <a:xfrm>
+            <a:off x="457200" y="868680"/>
+            <a:ext cx="11247120" cy="0"/>
+          </a:xfrm>
+          <a:prstGeom prst="line">
+            <a:avLst/>
+          </a:prstGeom>
+          <a:noFill/>
+          <a:ln w="12700">
+            <a:solidFill>
+              <a:srgbClr val="E2E8F0"/>
+            </a:solidFill>
+            <a:prstDash val="solid"/>
+          </a:ln>
+        </p:spPr>
+      </p:sp>
+      <p:sp>
+        <p:nvSpPr>
+          <p:cNvPr id="8" name="Text 4"/>
+          <p:cNvSpPr/>
+          <p:nvPr/>
+        </p:nvSpPr>
+        <p:spPr>
+          <a:xfrm>
+            <a:off x="2011680" y="182880"/>
+            <a:ext cx="8138160" cy="502920"/>
+          </a:xfrm>
+          <a:prstGeom prst="rect">
+            <a:avLst/>
+          </a:prstGeom>
+          <a:noFill/>
+          <a:ln/>
+        </p:spPr>
+        <p:txBody>
+          <a:bodyPr wrap="square" lIns="0" tIns="0" rIns="0" bIns="0" rtlCol="0" anchor="ctr"/>
+          <a:lstStyle/>
+          <a:p>
+            <a:pPr marL="0" indent="0" algn="ctr">
+              <a:buNone/>
+            </a:pPr>
+            <a:r>
+              <a:rPr lang="nl-NL" sz="2200" b="1">
+                <a:solidFill>
+                  <a:srgbClr val="1976D2"/>
+                </a:solidFill>
+                <a:latin typeface="Calibri" pitchFamily="34" charset="0"/>
+                <a:ea typeface="Calibri" pitchFamily="34" charset="-122"/>
+                <a:cs typeface="Calibri" pitchFamily="34" charset="-120"/>
+              </a:rPr>
+              <a:t>Bukti Git | repo Lab 01 terbit</a:t>
+            </a:r>
+            <a:endParaRPr lang="en-US" sz="2200" dirty="0"/>
+          </a:p>
+        </p:txBody>
+      </p:sp>
+      <p:sp>
+        <p:nvSpPr>
+          <p:cNvPr id="9" name="Text 5"/>
+          <p:cNvSpPr/>
+          <p:nvPr/>
+        </p:nvSpPr>
+        <p:spPr>
+          <a:xfrm>
+            <a:off x="457200" y="960120"/>
+            <a:ext cx="11247120" cy="320040"/>
+          </a:xfrm>
+          <a:prstGeom prst="rect">
+            <a:avLst/>
+          </a:prstGeom>
+          <a:noFill/>
+          <a:ln/>
+        </p:spPr>
+        <p:txBody>
+          <a:bodyPr wrap="square" lIns="0" tIns="0" rIns="0" bIns="0" rtlCol="0" anchor="ctr"/>
+          <a:lstStyle/>
+          <a:p>
+            <a:pPr marL="0" indent="0" algn="ctr">
+              <a:buNone/>
+            </a:pPr>
+            <a:r>
+              <a:rPr lang="en-US" sz="1200" i="1">
+                <a:solidFill>
+                  <a:srgbClr val="64748B"/>
+                </a:solidFill>
+                <a:latin typeface="Calibri" pitchFamily="34" charset="0"/>
+                <a:ea typeface="Calibri" pitchFamily="34" charset="-122"/>
+                <a:cs typeface="Calibri" pitchFamily="34" charset="-120"/>
+              </a:rPr>
+              <a:t>remote, status, log, SHA main  |  contoh checkpoint pengajar</a:t>
+            </a:r>
+            <a:endParaRPr lang="en-US" sz="1200" dirty="0"/>
+          </a:p>
+        </p:txBody>
+      </p:sp>
+      <p:sp>
+        <p:nvSpPr>
+          <p:cNvPr id="27" name="Rectangle 26">
+            <a:extLst>
+              <a:ext uri="{FF2B5EF4-FFF2-40B4-BE49-F238E27FC236}">
+                <a16:creationId xmlns:a16="http://schemas.microsoft.com/office/drawing/2014/main" id="{CA2C3FC3-2268-3632-60A5-8F36FCCD90BB}"/>
+              </a:ext>
+            </a:extLst>
+          </p:cNvPr>
+          <p:cNvSpPr/>
+          <p:nvPr/>
+        </p:nvSpPr>
+        <p:spPr>
+          <a:xfrm>
+            <a:off x="457200" y="1409700"/>
+            <a:ext cx="11252200" cy="3886200"/>
+          </a:xfrm>
+          <a:prstGeom prst="rect">
+            <a:avLst/>
+          </a:prstGeom>
+          <a:solidFill>
+            <a:srgbClr val="F6F8FC"/>
+          </a:solidFill>
+          <a:ln>
+            <a:solidFill>
+              <a:srgbClr val="D3DEEE"/>
+            </a:solidFill>
+          </a:ln>
+        </p:spPr>
+        <p:style>
+          <a:lnRef idx="2">
+            <a:schemeClr val="accent1">
+              <a:shade val="15000"/>
+            </a:schemeClr>
+          </a:lnRef>
+          <a:fillRef idx="1">
+            <a:schemeClr val="accent1"/>
+          </a:fillRef>
+          <a:effectRef idx="0">
+            <a:schemeClr val="accent1"/>
+          </a:effectRef>
+          <a:fontRef idx="minor">
+            <a:schemeClr val="lt1"/>
+          </a:fontRef>
+        </p:style>
+        <p:txBody>
+          <a:bodyPr rtlCol="0" anchor="ctr"/>
+          <a:lstStyle/>
+          <a:p>
+            <a:pPr algn="ctr"/>
+            <a:endParaRPr lang="en-US"/>
+          </a:p>
+        </p:txBody>
+      </p:sp>
+      <p:sp>
+        <p:nvSpPr>
+          <p:cNvPr id="30" name="Rectangle 29">
+            <a:extLst>
+              <a:ext uri="{FF2B5EF4-FFF2-40B4-BE49-F238E27FC236}">
+                <a16:creationId xmlns:a16="http://schemas.microsoft.com/office/drawing/2014/main" id="{784C38AF-D50D-3EDB-2A20-35E588144107}"/>
+              </a:ext>
+            </a:extLst>
+          </p:cNvPr>
+          <p:cNvSpPr/>
+          <p:nvPr/>
+        </p:nvSpPr>
+        <p:spPr>
+          <a:xfrm>
+            <a:off x="457200" y="5397500"/>
+            <a:ext cx="11252200" cy="787400"/>
+          </a:xfrm>
+          <a:prstGeom prst="rect">
+            <a:avLst/>
+          </a:prstGeom>
+          <a:solidFill>
+            <a:srgbClr val="002777"/>
+          </a:solidFill>
+          <a:ln w="12700" cap="flat" cmpd="sng" algn="ctr">
+            <a:noFill/>
+            <a:prstDash val="solid"/>
+            <a:miter lim="800000"/>
+          </a:ln>
+          <a:effectLst/>
+          <a:extLst>
+            <a:ext uri="{91240B29-F687-4F45-9708-019B960494DF}">
+              <a14:hiddenLine xmlns:a14="http://schemas.microsoft.com/office/drawing/2010/main" w="12700" cap="flat" cmpd="sng" algn="ctr">
+                <a:solidFill>
+                  <a:schemeClr val="accent1">
+                    <a:shade val="15000"/>
+                  </a:schemeClr>
+                </a:solidFill>
+                <a:prstDash val="solid"/>
+                <a:miter lim="800000"/>
+              </a14:hiddenLine>
+            </a:ext>
+          </a:extLst>
+        </p:spPr>
+        <p:style>
+          <a:lnRef idx="2">
+            <a:schemeClr val="accent1">
+              <a:shade val="15000"/>
+            </a:schemeClr>
+          </a:lnRef>
+          <a:fillRef idx="1">
+            <a:schemeClr val="accent1"/>
+          </a:fillRef>
+          <a:effectRef idx="0">
+            <a:schemeClr val="accent1"/>
+          </a:effectRef>
+          <a:fontRef idx="minor">
+            <a:schemeClr val="lt1"/>
+          </a:fontRef>
+        </p:style>
+        <p:txBody>
+          <a:bodyPr rtlCol="0" anchor="ctr"/>
+          <a:lstStyle/>
+          <a:p>
+            <a:pPr algn="ctr"/>
+            <a:endParaRPr lang="en-US"/>
+          </a:p>
+        </p:txBody>
+      </p:sp>
+      <p:sp>
+        <p:nvSpPr>
+          <p:cNvPr id="31" name="TextBox 30">
+            <a:extLst>
+              <a:ext uri="{FF2B5EF4-FFF2-40B4-BE49-F238E27FC236}">
+                <a16:creationId xmlns:a16="http://schemas.microsoft.com/office/drawing/2014/main" id="{78179848-0254-FC95-B234-981E0248F004}"/>
+              </a:ext>
+            </a:extLst>
+          </p:cNvPr>
+          <p:cNvSpPr txBox="1"/>
+          <p:nvPr/>
+        </p:nvSpPr>
+        <p:spPr>
+          <a:xfrm>
+            <a:off x="635000" y="5499100"/>
+            <a:ext cx="3429000" cy="276999"/>
+          </a:xfrm>
+          <a:prstGeom prst="rect">
+            <a:avLst/>
+          </a:prstGeom>
+          <a:noFill/>
+        </p:spPr>
+        <p:txBody>
+          <a:bodyPr vert="horz" wrap="square" lIns="0" tIns="0" rIns="0" bIns="0" rtlCol="0">
+            <a:noAutofit/>
+          </a:bodyPr>
+          <a:lstStyle/>
+          <a:p>
+            <a:r>
+              <a:rPr lang="en-US" sz="1050" b="1">
+                <a:solidFill>
+                  <a:srgbClr val="F37021"/>
+                </a:solidFill>
+                <a:latin typeface="Arial" panose="020B0604020202020204" pitchFamily="34" charset="0"/>
+              </a:rPr>
+              <a:t>TUJUAN</a:t>
+            </a:r>
+          </a:p>
+        </p:txBody>
+      </p:sp>
+      <p:sp>
+        <p:nvSpPr>
+          <p:cNvPr id="32" name="TextBox 31">
+            <a:extLst>
+              <a:ext uri="{FF2B5EF4-FFF2-40B4-BE49-F238E27FC236}">
+                <a16:creationId xmlns:a16="http://schemas.microsoft.com/office/drawing/2014/main" id="{9F041FD0-C768-9242-FF37-021E9D2B6BD9}"/>
+              </a:ext>
+            </a:extLst>
+          </p:cNvPr>
+          <p:cNvSpPr txBox="1"/>
+          <p:nvPr/>
+        </p:nvSpPr>
+        <p:spPr>
+          <a:xfrm>
+            <a:off x="635000" y="5727700"/>
+            <a:ext cx="3429000" cy="276999"/>
+          </a:xfrm>
+          <a:prstGeom prst="rect">
+            <a:avLst/>
+          </a:prstGeom>
+          <a:noFill/>
+        </p:spPr>
+        <p:txBody>
+          <a:bodyPr vert="horz" wrap="square" lIns="0" tIns="0" rIns="0" bIns="0" rtlCol="0">
+            <a:noAutofit/>
+          </a:bodyPr>
+          <a:lstStyle/>
+          <a:p>
+            <a:r>
+              <a:rPr lang="en-US" sz="1300">
+                <a:solidFill>
+                  <a:srgbClr val="FFFFFF"/>
+                </a:solidFill>
+                <a:latin typeface="Arial" panose="020B0604020202020204" pitchFamily="34" charset="0"/>
+              </a:rPr>
+              <a:t>origin = meet1CloudService</a:t>
+            </a:r>
+          </a:p>
+        </p:txBody>
+      </p:sp>
+      <p:sp>
+        <p:nvSpPr>
+          <p:cNvPr id="33" name="TextBox 32">
+            <a:extLst>
+              <a:ext uri="{FF2B5EF4-FFF2-40B4-BE49-F238E27FC236}">
+                <a16:creationId xmlns:a16="http://schemas.microsoft.com/office/drawing/2014/main" id="{AF74B100-F150-BE1A-A13C-CBD2FCE7D19B}"/>
+              </a:ext>
+            </a:extLst>
+          </p:cNvPr>
+          <p:cNvSpPr txBox="1"/>
+          <p:nvPr/>
+        </p:nvSpPr>
+        <p:spPr>
+          <a:xfrm>
+            <a:off x="4318000" y="5499100"/>
+            <a:ext cx="3429000" cy="276999"/>
+          </a:xfrm>
+          <a:prstGeom prst="rect">
+            <a:avLst/>
+          </a:prstGeom>
+          <a:noFill/>
+        </p:spPr>
+        <p:txBody>
+          <a:bodyPr vert="horz" wrap="square" lIns="0" tIns="0" rIns="0" bIns="0" rtlCol="0">
+            <a:noAutofit/>
+          </a:bodyPr>
+          <a:lstStyle/>
+          <a:p>
+            <a:r>
+              <a:rPr lang="en-US" sz="1050" b="1">
+                <a:solidFill>
+                  <a:srgbClr val="F37021"/>
+                </a:solidFill>
+                <a:latin typeface="Arial" panose="020B0604020202020204" pitchFamily="34" charset="0"/>
+              </a:rPr>
+              <a:t>HASIL PUSH</a:t>
+            </a:r>
+          </a:p>
+        </p:txBody>
+      </p:sp>
+      <p:sp>
+        <p:nvSpPr>
+          <p:cNvPr id="34" name="TextBox 33">
+            <a:extLst>
+              <a:ext uri="{FF2B5EF4-FFF2-40B4-BE49-F238E27FC236}">
+                <a16:creationId xmlns:a16="http://schemas.microsoft.com/office/drawing/2014/main" id="{B864305D-94C1-CBA2-4912-2EC5B118054C}"/>
+              </a:ext>
+            </a:extLst>
+          </p:cNvPr>
+          <p:cNvSpPr txBox="1"/>
+          <p:nvPr/>
+        </p:nvSpPr>
+        <p:spPr>
+          <a:xfrm>
+            <a:off x="4318000" y="5727700"/>
+            <a:ext cx="3429000" cy="276999"/>
+          </a:xfrm>
+          <a:prstGeom prst="rect">
+            <a:avLst/>
+          </a:prstGeom>
+          <a:noFill/>
+        </p:spPr>
+        <p:txBody>
+          <a:bodyPr vert="horz" wrap="square" lIns="0" tIns="0" rIns="0" bIns="0" rtlCol="0">
+            <a:noAutofit/>
+          </a:bodyPr>
+          <a:lstStyle/>
+          <a:p>
+            <a:r>
+              <a:rPr lang="en-US" sz="1300">
+                <a:solidFill>
+                  <a:srgbClr val="FFFFFF"/>
+                </a:solidFill>
+                <a:latin typeface="Arial" panose="020B0604020202020204" pitchFamily="34" charset="0"/>
+              </a:rPr>
+              <a:t>SHA lokal = remote saat uji</a:t>
+            </a:r>
+          </a:p>
+        </p:txBody>
+      </p:sp>
+      <p:sp>
+        <p:nvSpPr>
+          <p:cNvPr id="35" name="TextBox 34">
+            <a:extLst>
+              <a:ext uri="{FF2B5EF4-FFF2-40B4-BE49-F238E27FC236}">
+                <a16:creationId xmlns:a16="http://schemas.microsoft.com/office/drawing/2014/main" id="{7FEE0EF9-5060-12FC-A5E6-E5367599FF83}"/>
+              </a:ext>
+            </a:extLst>
+          </p:cNvPr>
+          <p:cNvSpPr txBox="1"/>
+          <p:nvPr/>
+        </p:nvSpPr>
+        <p:spPr>
+          <a:xfrm>
+            <a:off x="8001000" y="5499100"/>
+            <a:ext cx="3429000" cy="276999"/>
+          </a:xfrm>
+          <a:prstGeom prst="rect">
+            <a:avLst/>
+          </a:prstGeom>
+          <a:noFill/>
+        </p:spPr>
+        <p:txBody>
+          <a:bodyPr vert="horz" wrap="square" lIns="0" tIns="0" rIns="0" bIns="0" rtlCol="0">
+            <a:noAutofit/>
+          </a:bodyPr>
+          <a:lstStyle/>
+          <a:p>
+            <a:r>
+              <a:rPr lang="en-US" sz="1050" b="1">
+                <a:solidFill>
+                  <a:srgbClr val="F37021"/>
+                </a:solidFill>
+                <a:latin typeface="Arial" panose="020B0604020202020204" pitchFamily="34" charset="0"/>
+              </a:rPr>
+              <a:t>MAHASISWA</a:t>
+            </a:r>
+          </a:p>
+        </p:txBody>
+      </p:sp>
+      <p:sp>
+        <p:nvSpPr>
+          <p:cNvPr id="36" name="TextBox 35">
+            <a:extLst>
+              <a:ext uri="{FF2B5EF4-FFF2-40B4-BE49-F238E27FC236}">
+                <a16:creationId xmlns:a16="http://schemas.microsoft.com/office/drawing/2014/main" id="{B7FAF8FA-E512-3BA5-B85A-15159888CAEB}"/>
+              </a:ext>
+            </a:extLst>
+          </p:cNvPr>
+          <p:cNvSpPr txBox="1"/>
+          <p:nvPr/>
+        </p:nvSpPr>
+        <p:spPr>
+          <a:xfrm>
+            <a:off x="8001000" y="5727700"/>
+            <a:ext cx="3429000" cy="276999"/>
+          </a:xfrm>
+          <a:prstGeom prst="rect">
+            <a:avLst/>
+          </a:prstGeom>
+          <a:noFill/>
+        </p:spPr>
+        <p:txBody>
+          <a:bodyPr vert="horz" wrap="square" lIns="0" tIns="0" rIns="0" bIns="0" rtlCol="0">
+            <a:noAutofit/>
+          </a:bodyPr>
+          <a:lstStyle/>
+          <a:p>
+            <a:r>
+              <a:rPr lang="en-US" sz="1300">
+                <a:solidFill>
+                  <a:srgbClr val="FFFFFF"/>
+                </a:solidFill>
+                <a:latin typeface="Arial" panose="020B0604020202020204" pitchFamily="34" charset="0"/>
+              </a:rPr>
+              <a:t>Ulangi pada repo pribadi</a:t>
+            </a:r>
+          </a:p>
+        </p:txBody>
+      </p:sp>
+      <p:pic>
+        <p:nvPicPr>
+          <p:cNvPr id="37" name="Picture 36" descr="image.png"/>
+          <p:cNvPicPr>
+            <a:picLocks noChangeAspect="1"/>
+          </p:cNvPicPr>
+          <p:nvPr/>
+        </p:nvPicPr>
+        <p:blipFill>
+          <a:blip r:embed="rId4"/>
+          <a:stretch>
+            <a:fillRect/>
+          </a:stretch>
+        </p:blipFill>
+        <p:spPr>
+          <a:xfrm>
+            <a:off x="1146439" y="1490898"/>
+            <a:ext cx="9873722" cy="3723804"/>
+          </a:xfrm>
+          <a:prstGeom prst="rect">
+            <a:avLst/>
+          </a:prstGeom>
+        </p:spPr>
+      </p:pic>
+    </p:spTree>
   </p:cSld>
   <p:clrMapOvr>
     <a:masterClrMapping/>

</xml_diff>